<commit_message>
updated easy and hard problems PowerPoint
</commit_message>
<xml_diff>
--- a/notes/week13/Easy_and_Hard_Problems.pptx
+++ b/notes/week13/Easy_and_Hard_Problems.pptx
@@ -5,7 +5,7 @@
     <p:sldMasterId id="2147483648" r:id="rId1"/>
   </p:sldMasterIdLst>
   <p:notesMasterIdLst>
-    <p:notesMasterId r:id="rId25"/>
+    <p:notesMasterId r:id="rId26"/>
   </p:notesMasterIdLst>
   <p:sldIdLst>
     <p:sldId id="256" r:id="rId2"/>
@@ -26,11 +26,12 @@
     <p:sldId id="275" r:id="rId17"/>
     <p:sldId id="262" r:id="rId18"/>
     <p:sldId id="263" r:id="rId19"/>
-    <p:sldId id="276" r:id="rId20"/>
-    <p:sldId id="277" r:id="rId21"/>
-    <p:sldId id="278" r:id="rId22"/>
-    <p:sldId id="264" r:id="rId23"/>
-    <p:sldId id="265" r:id="rId24"/>
+    <p:sldId id="279" r:id="rId20"/>
+    <p:sldId id="276" r:id="rId21"/>
+    <p:sldId id="277" r:id="rId22"/>
+    <p:sldId id="278" r:id="rId23"/>
+    <p:sldId id="264" r:id="rId24"/>
+    <p:sldId id="265" r:id="rId25"/>
   </p:sldIdLst>
   <p:sldSz cx="9144000" cy="5143500" type="screen16x9"/>
   <p:notesSz cx="5143500" cy="9144000"/>
@@ -132,6 +133,82 @@
     </p:ext>
   </p:extLst>
 </p:presentation>
+</file>
+
+<file path=ppt/changesInfos/changesInfo1.xml><?xml version="1.0" encoding="utf-8"?>
+<pc:chgInfo xmlns:a="http://schemas.openxmlformats.org/drawingml/2006/main" xmlns:r="http://schemas.openxmlformats.org/officeDocument/2006/relationships" xmlns:ac="http://schemas.microsoft.com/office/drawing/2013/main/command" xmlns:pc="http://schemas.microsoft.com/office/powerpoint/2013/main/command">
+  <pc:docChgLst>
+    <pc:chgData name="Toby Donaldson" userId="2e6e5431-bb17-4c41-9985-d39c50d83c73" providerId="ADAL" clId="{F31BC264-820E-54C4-A6D1-F92AF9CC222E}"/>
+    <pc:docChg chg="custSel addSld modSld">
+      <pc:chgData name="Toby Donaldson" userId="2e6e5431-bb17-4c41-9985-d39c50d83c73" providerId="ADAL" clId="{F31BC264-820E-54C4-A6D1-F92AF9CC222E}" dt="2026-03-30T23:41:27.414" v="7" actId="1076"/>
+      <pc:docMkLst>
+        <pc:docMk/>
+      </pc:docMkLst>
+      <pc:sldChg chg="addSp delSp modSp mod">
+        <pc:chgData name="Toby Donaldson" userId="2e6e5431-bb17-4c41-9985-d39c50d83c73" providerId="ADAL" clId="{F31BC264-820E-54C4-A6D1-F92AF9CC222E}" dt="2026-03-30T23:41:27.414" v="7" actId="1076"/>
+        <pc:sldMkLst>
+          <pc:docMk/>
+          <pc:sldMk cId="0" sldId="263"/>
+        </pc:sldMkLst>
+        <pc:spChg chg="del">
+          <ac:chgData name="Toby Donaldson" userId="2e6e5431-bb17-4c41-9985-d39c50d83c73" providerId="ADAL" clId="{F31BC264-820E-54C4-A6D1-F92AF9CC222E}" dt="2026-03-30T23:41:13.346" v="2" actId="21"/>
+          <ac:spMkLst>
+            <pc:docMk/>
+            <pc:sldMk cId="0" sldId="263"/>
+            <ac:spMk id="5" creationId="{00000000-0000-0000-0000-000000000000}"/>
+          </ac:spMkLst>
+        </pc:spChg>
+        <pc:spChg chg="del">
+          <ac:chgData name="Toby Donaldson" userId="2e6e5431-bb17-4c41-9985-d39c50d83c73" providerId="ADAL" clId="{F31BC264-820E-54C4-A6D1-F92AF9CC222E}" dt="2026-03-30T23:41:08.897" v="1" actId="21"/>
+          <ac:spMkLst>
+            <pc:docMk/>
+            <pc:sldMk cId="0" sldId="263"/>
+            <ac:spMk id="6" creationId="{00000000-0000-0000-0000-000000000000}"/>
+          </ac:spMkLst>
+        </pc:spChg>
+        <pc:spChg chg="del">
+          <ac:chgData name="Toby Donaldson" userId="2e6e5431-bb17-4c41-9985-d39c50d83c73" providerId="ADAL" clId="{F31BC264-820E-54C4-A6D1-F92AF9CC222E}" dt="2026-03-30T23:41:08.897" v="1" actId="21"/>
+          <ac:spMkLst>
+            <pc:docMk/>
+            <pc:sldMk cId="0" sldId="263"/>
+            <ac:spMk id="7" creationId="{00000000-0000-0000-0000-000000000000}"/>
+          </ac:spMkLst>
+        </pc:spChg>
+        <pc:spChg chg="del">
+          <ac:chgData name="Toby Donaldson" userId="2e6e5431-bb17-4c41-9985-d39c50d83c73" providerId="ADAL" clId="{F31BC264-820E-54C4-A6D1-F92AF9CC222E}" dt="2026-03-30T23:41:08.897" v="1" actId="21"/>
+          <ac:spMkLst>
+            <pc:docMk/>
+            <pc:sldMk cId="0" sldId="263"/>
+            <ac:spMk id="8" creationId="{00000000-0000-0000-0000-000000000000}"/>
+          </ac:spMkLst>
+        </pc:spChg>
+        <pc:spChg chg="del">
+          <ac:chgData name="Toby Donaldson" userId="2e6e5431-bb17-4c41-9985-d39c50d83c73" providerId="ADAL" clId="{F31BC264-820E-54C4-A6D1-F92AF9CC222E}" dt="2026-03-30T23:41:08.897" v="1" actId="21"/>
+          <ac:spMkLst>
+            <pc:docMk/>
+            <pc:sldMk cId="0" sldId="263"/>
+            <ac:spMk id="9" creationId="{00000000-0000-0000-0000-000000000000}"/>
+          </ac:spMkLst>
+        </pc:spChg>
+        <pc:picChg chg="add mod">
+          <ac:chgData name="Toby Donaldson" userId="2e6e5431-bb17-4c41-9985-d39c50d83c73" providerId="ADAL" clId="{F31BC264-820E-54C4-A6D1-F92AF9CC222E}" dt="2026-03-30T23:41:27.414" v="7" actId="1076"/>
+          <ac:picMkLst>
+            <pc:docMk/>
+            <pc:sldMk cId="0" sldId="263"/>
+            <ac:picMk id="11" creationId="{72A7C797-9746-1073-046B-F02859C2D756}"/>
+          </ac:picMkLst>
+        </pc:picChg>
+      </pc:sldChg>
+      <pc:sldChg chg="add">
+        <pc:chgData name="Toby Donaldson" userId="2e6e5431-bb17-4c41-9985-d39c50d83c73" providerId="ADAL" clId="{F31BC264-820E-54C4-A6D1-F92AF9CC222E}" dt="2026-03-30T23:40:59.364" v="0" actId="2890"/>
+        <pc:sldMkLst>
+          <pc:docMk/>
+          <pc:sldMk cId="1515791411" sldId="279"/>
+        </pc:sldMkLst>
+      </pc:sldChg>
+    </pc:docChg>
+  </pc:docChgLst>
+</pc:chgInfo>
 </file>
 
 <file path=ppt/notesMasters/notesMaster1.xml><?xml version="1.0" encoding="utf-8"?>
@@ -1203,7 +1280,7 @@
         <p:cNvPr id="1" name="">
           <a:extLst>
             <a:ext uri="{FF2B5EF4-FFF2-40B4-BE49-F238E27FC236}">
-              <a16:creationId xmlns:a16="http://schemas.microsoft.com/office/drawing/2014/main" id="{68348C43-D524-997D-968B-2459FC66775A}"/>
+              <a16:creationId xmlns:a16="http://schemas.microsoft.com/office/drawing/2014/main" id="{6DF46E6A-81A4-F954-1ED7-F8142D97EB91}"/>
             </a:ext>
           </a:extLst>
         </p:cNvPr>
@@ -1223,7 +1300,7 @@
           <p:cNvPr id="2" name="Slide Image Placeholder 1">
             <a:extLst>
               <a:ext uri="{FF2B5EF4-FFF2-40B4-BE49-F238E27FC236}">
-                <a16:creationId xmlns:a16="http://schemas.microsoft.com/office/drawing/2014/main" id="{79FB4B40-F962-FD39-70A8-E99EE66E98DD}"/>
+                <a16:creationId xmlns:a16="http://schemas.microsoft.com/office/drawing/2014/main" id="{327859D6-684B-A4E7-D88F-A5A3965CEC75}"/>
               </a:ext>
             </a:extLst>
           </p:cNvPr>
@@ -1241,7 +1318,7 @@
           <p:cNvPr id="3" name="Notes Placeholder 2">
             <a:extLst>
               <a:ext uri="{FF2B5EF4-FFF2-40B4-BE49-F238E27FC236}">
-                <a16:creationId xmlns:a16="http://schemas.microsoft.com/office/drawing/2014/main" id="{F3DE2B2E-D46D-62FB-6595-EE6B0E4F725C}"/>
+                <a16:creationId xmlns:a16="http://schemas.microsoft.com/office/drawing/2014/main" id="{FA20817D-35DF-26A2-03EE-FE54C568BB99}"/>
               </a:ext>
             </a:extLst>
           </p:cNvPr>
@@ -1266,7 +1343,7 @@
           <p:cNvPr id="4" name="Slide Number Placeholder 3">
             <a:extLst>
               <a:ext uri="{FF2B5EF4-FFF2-40B4-BE49-F238E27FC236}">
-                <a16:creationId xmlns:a16="http://schemas.microsoft.com/office/drawing/2014/main" id="{DE534D3B-4BAD-6EF3-4831-E6BD47E2FE6E}"/>
+                <a16:creationId xmlns:a16="http://schemas.microsoft.com/office/drawing/2014/main" id="{1006C9E1-BCC0-F5B1-C72A-33DE49ADD1F6}"/>
               </a:ext>
             </a:extLst>
           </p:cNvPr>
@@ -1293,7 +1370,7 @@
     </p:spTree>
     <p:extLst>
       <p:ext uri="{BB962C8B-B14F-4D97-AF65-F5344CB8AC3E}">
-        <p14:creationId xmlns:p14="http://schemas.microsoft.com/office/powerpoint/2010/main" val="3837646465"/>
+        <p14:creationId xmlns:p14="http://schemas.microsoft.com/office/powerpoint/2010/main" val="3750654940"/>
       </p:ext>
     </p:extLst>
   </p:cSld>
@@ -1395,6 +1472,114 @@
         <p:cNvPr id="1" name="">
           <a:extLst>
             <a:ext uri="{FF2B5EF4-FFF2-40B4-BE49-F238E27FC236}">
+              <a16:creationId xmlns:a16="http://schemas.microsoft.com/office/drawing/2014/main" id="{68348C43-D524-997D-968B-2459FC66775A}"/>
+            </a:ext>
+          </a:extLst>
+        </p:cNvPr>
+        <p:cNvGrpSpPr/>
+        <p:nvPr/>
+      </p:nvGrpSpPr>
+      <p:grpSpPr>
+        <a:xfrm>
+          <a:off x="0" y="0"/>
+          <a:ext cx="0" cy="0"/>
+          <a:chOff x="0" y="0"/>
+          <a:chExt cx="0" cy="0"/>
+        </a:xfrm>
+      </p:grpSpPr>
+      <p:sp>
+        <p:nvSpPr>
+          <p:cNvPr id="2" name="Slide Image Placeholder 1">
+            <a:extLst>
+              <a:ext uri="{FF2B5EF4-FFF2-40B4-BE49-F238E27FC236}">
+                <a16:creationId xmlns:a16="http://schemas.microsoft.com/office/drawing/2014/main" id="{79FB4B40-F962-FD39-70A8-E99EE66E98DD}"/>
+              </a:ext>
+            </a:extLst>
+          </p:cNvPr>
+          <p:cNvSpPr>
+            <a:spLocks noGrp="1" noRot="1" noChangeAspect="1"/>
+          </p:cNvSpPr>
+          <p:nvPr>
+            <p:ph type="sldImg"/>
+          </p:nvPr>
+        </p:nvSpPr>
+        <p:spPr/>
+      </p:sp>
+      <p:sp>
+        <p:nvSpPr>
+          <p:cNvPr id="3" name="Notes Placeholder 2">
+            <a:extLst>
+              <a:ext uri="{FF2B5EF4-FFF2-40B4-BE49-F238E27FC236}">
+                <a16:creationId xmlns:a16="http://schemas.microsoft.com/office/drawing/2014/main" id="{F3DE2B2E-D46D-62FB-6595-EE6B0E4F725C}"/>
+              </a:ext>
+            </a:extLst>
+          </p:cNvPr>
+          <p:cNvSpPr>
+            <a:spLocks noGrp="1"/>
+          </p:cNvSpPr>
+          <p:nvPr>
+            <p:ph type="body" idx="1"/>
+          </p:nvPr>
+        </p:nvSpPr>
+        <p:spPr/>
+        <p:txBody>
+          <a:bodyPr/>
+          <a:lstStyle/>
+          <a:p>
+            <a:endParaRPr lang="en-US" dirty="0"/>
+          </a:p>
+        </p:txBody>
+      </p:sp>
+      <p:sp>
+        <p:nvSpPr>
+          <p:cNvPr id="4" name="Slide Number Placeholder 3">
+            <a:extLst>
+              <a:ext uri="{FF2B5EF4-FFF2-40B4-BE49-F238E27FC236}">
+                <a16:creationId xmlns:a16="http://schemas.microsoft.com/office/drawing/2014/main" id="{DE534D3B-4BAD-6EF3-4831-E6BD47E2FE6E}"/>
+              </a:ext>
+            </a:extLst>
+          </p:cNvPr>
+          <p:cNvSpPr>
+            <a:spLocks noGrp="1"/>
+          </p:cNvSpPr>
+          <p:nvPr>
+            <p:ph type="sldNum" sz="quarter" idx="10"/>
+          </p:nvPr>
+        </p:nvSpPr>
+        <p:spPr/>
+        <p:txBody>
+          <a:bodyPr/>
+          <a:lstStyle/>
+          <a:p>
+            <a:fld id="{F7021451-1387-4CA6-816F-3879F97B5CBC}" type="slidenum">
+              <a:rPr lang="en-US"/>
+              <a:t>20</a:t>
+            </a:fld>
+            <a:endParaRPr lang="en-US"/>
+          </a:p>
+        </p:txBody>
+      </p:sp>
+    </p:spTree>
+    <p:extLst>
+      <p:ext uri="{BB962C8B-B14F-4D97-AF65-F5344CB8AC3E}">
+        <p14:creationId xmlns:p14="http://schemas.microsoft.com/office/powerpoint/2010/main" val="3837646465"/>
+      </p:ext>
+    </p:extLst>
+  </p:cSld>
+  <p:clrMapOvr>
+    <a:masterClrMapping/>
+  </p:clrMapOvr>
+</p:notes>
+</file>
+
+<file path=ppt/notesSlides/notesSlide21.xml><?xml version="1.0" encoding="utf-8"?>
+<p:notes xmlns:a="http://schemas.openxmlformats.org/drawingml/2006/main" xmlns:r="http://schemas.openxmlformats.org/officeDocument/2006/relationships" xmlns:p="http://schemas.openxmlformats.org/presentationml/2006/main">
+  <p:cSld>
+    <p:spTree>
+      <p:nvGrpSpPr>
+        <p:cNvPr id="1" name="">
+          <a:extLst>
+            <a:ext uri="{FF2B5EF4-FFF2-40B4-BE49-F238E27FC236}">
               <a16:creationId xmlns:a16="http://schemas.microsoft.com/office/drawing/2014/main" id="{6C3D0111-151A-5A68-A9FC-7D92A9A34200}"/>
             </a:ext>
           </a:extLst>
@@ -1476,7 +1661,7 @@
           <a:p>
             <a:fld id="{F7021451-1387-4CA6-816F-3879F97B5CBC}" type="slidenum">
               <a:rPr lang="en-US"/>
-              <a:t>20</a:t>
+              <a:t>21</a:t>
             </a:fld>
             <a:endParaRPr lang="en-US"/>
           </a:p>
@@ -1495,7 +1680,7 @@
 </p:notes>
 </file>
 
-<file path=ppt/notesSlides/notesSlide21.xml><?xml version="1.0" encoding="utf-8"?>
+<file path=ppt/notesSlides/notesSlide22.xml><?xml version="1.0" encoding="utf-8"?>
 <p:notes xmlns:a="http://schemas.openxmlformats.org/drawingml/2006/main" xmlns:r="http://schemas.openxmlformats.org/officeDocument/2006/relationships" xmlns:p="http://schemas.openxmlformats.org/presentationml/2006/main">
   <p:cSld>
     <p:spTree>
@@ -1584,7 +1769,7 @@
           <a:p>
             <a:fld id="{F7021451-1387-4CA6-816F-3879F97B5CBC}" type="slidenum">
               <a:rPr lang="en-US"/>
-              <a:t>21</a:t>
+              <a:t>22</a:t>
             </a:fld>
             <a:endParaRPr lang="en-US"/>
           </a:p>
@@ -1594,90 +1779,6 @@
     <p:extLst>
       <p:ext uri="{BB962C8B-B14F-4D97-AF65-F5344CB8AC3E}">
         <p14:creationId xmlns:p14="http://schemas.microsoft.com/office/powerpoint/2010/main" val="3108915207"/>
-      </p:ext>
-    </p:extLst>
-  </p:cSld>
-  <p:clrMapOvr>
-    <a:masterClrMapping/>
-  </p:clrMapOvr>
-</p:notes>
-</file>
-
-<file path=ppt/notesSlides/notesSlide22.xml><?xml version="1.0" encoding="utf-8"?>
-<p:notes xmlns:a="http://schemas.openxmlformats.org/drawingml/2006/main" xmlns:r="http://schemas.openxmlformats.org/officeDocument/2006/relationships" xmlns:p="http://schemas.openxmlformats.org/presentationml/2006/main">
-  <p:cSld>
-    <p:spTree>
-      <p:nvGrpSpPr>
-        <p:cNvPr id="1" name=""/>
-        <p:cNvGrpSpPr/>
-        <p:nvPr/>
-      </p:nvGrpSpPr>
-      <p:grpSpPr>
-        <a:xfrm>
-          <a:off x="0" y="0"/>
-          <a:ext cx="0" cy="0"/>
-          <a:chOff x="0" y="0"/>
-          <a:chExt cx="0" cy="0"/>
-        </a:xfrm>
-      </p:grpSpPr>
-      <p:sp>
-        <p:nvSpPr>
-          <p:cNvPr id="2" name="Slide Image Placeholder 1"/>
-          <p:cNvSpPr>
-            <a:spLocks noGrp="1" noRot="1" noChangeAspect="1"/>
-          </p:cNvSpPr>
-          <p:nvPr>
-            <p:ph type="sldImg"/>
-          </p:nvPr>
-        </p:nvSpPr>
-        <p:spPr/>
-      </p:sp>
-      <p:sp>
-        <p:nvSpPr>
-          <p:cNvPr id="3" name="Notes Placeholder 2"/>
-          <p:cNvSpPr>
-            <a:spLocks noGrp="1"/>
-          </p:cNvSpPr>
-          <p:nvPr>
-            <p:ph type="body" idx="1"/>
-          </p:nvPr>
-        </p:nvSpPr>
-        <p:spPr/>
-        <p:txBody>
-          <a:bodyPr/>
-          <a:lstStyle/>
-          <a:p>
-            <a:endParaRPr lang="en-US" dirty="0"/>
-          </a:p>
-        </p:txBody>
-      </p:sp>
-      <p:sp>
-        <p:nvSpPr>
-          <p:cNvPr id="4" name="Slide Number Placeholder 3"/>
-          <p:cNvSpPr>
-            <a:spLocks noGrp="1"/>
-          </p:cNvSpPr>
-          <p:nvPr>
-            <p:ph type="sldNum" sz="quarter" idx="10"/>
-          </p:nvPr>
-        </p:nvSpPr>
-        <p:spPr/>
-        <p:txBody>
-          <a:bodyPr/>
-          <a:lstStyle/>
-          <a:p>
-            <a:fld id="{F7021451-1387-4CA6-816F-3879F97B5CBC}" type="slidenum">
-              <a:rPr lang="en-US"/>
-              <a:t>22</a:t>
-            </a:fld>
-            <a:endParaRPr lang="en-US"/>
-          </a:p>
-        </p:txBody>
-      </p:sp>
-    </p:spTree>
-    <p:extLst>
-      <p:ext uri="{BB962C8B-B14F-4D97-AF65-F5344CB8AC3E}">
-        <p14:creationId xmlns:p14="http://schemas.microsoft.com/office/powerpoint/2010/main" val="1024086991"/>
       </p:ext>
     </p:extLst>
   </p:cSld>
@@ -1753,6 +1854,90 @@
             <a:fld id="{F7021451-1387-4CA6-816F-3879F97B5CBC}" type="slidenum">
               <a:rPr lang="en-US"/>
               <a:t>23</a:t>
+            </a:fld>
+            <a:endParaRPr lang="en-US"/>
+          </a:p>
+        </p:txBody>
+      </p:sp>
+    </p:spTree>
+    <p:extLst>
+      <p:ext uri="{BB962C8B-B14F-4D97-AF65-F5344CB8AC3E}">
+        <p14:creationId xmlns:p14="http://schemas.microsoft.com/office/powerpoint/2010/main" val="1024086991"/>
+      </p:ext>
+    </p:extLst>
+  </p:cSld>
+  <p:clrMapOvr>
+    <a:masterClrMapping/>
+  </p:clrMapOvr>
+</p:notes>
+</file>
+
+<file path=ppt/notesSlides/notesSlide24.xml><?xml version="1.0" encoding="utf-8"?>
+<p:notes xmlns:a="http://schemas.openxmlformats.org/drawingml/2006/main" xmlns:r="http://schemas.openxmlformats.org/officeDocument/2006/relationships" xmlns:p="http://schemas.openxmlformats.org/presentationml/2006/main">
+  <p:cSld>
+    <p:spTree>
+      <p:nvGrpSpPr>
+        <p:cNvPr id="1" name=""/>
+        <p:cNvGrpSpPr/>
+        <p:nvPr/>
+      </p:nvGrpSpPr>
+      <p:grpSpPr>
+        <a:xfrm>
+          <a:off x="0" y="0"/>
+          <a:ext cx="0" cy="0"/>
+          <a:chOff x="0" y="0"/>
+          <a:chExt cx="0" cy="0"/>
+        </a:xfrm>
+      </p:grpSpPr>
+      <p:sp>
+        <p:nvSpPr>
+          <p:cNvPr id="2" name="Slide Image Placeholder 1"/>
+          <p:cNvSpPr>
+            <a:spLocks noGrp="1" noRot="1" noChangeAspect="1"/>
+          </p:cNvSpPr>
+          <p:nvPr>
+            <p:ph type="sldImg"/>
+          </p:nvPr>
+        </p:nvSpPr>
+        <p:spPr/>
+      </p:sp>
+      <p:sp>
+        <p:nvSpPr>
+          <p:cNvPr id="3" name="Notes Placeholder 2"/>
+          <p:cNvSpPr>
+            <a:spLocks noGrp="1"/>
+          </p:cNvSpPr>
+          <p:nvPr>
+            <p:ph type="body" idx="1"/>
+          </p:nvPr>
+        </p:nvSpPr>
+        <p:spPr/>
+        <p:txBody>
+          <a:bodyPr/>
+          <a:lstStyle/>
+          <a:p>
+            <a:endParaRPr lang="en-US" dirty="0"/>
+          </a:p>
+        </p:txBody>
+      </p:sp>
+      <p:sp>
+        <p:nvSpPr>
+          <p:cNvPr id="4" name="Slide Number Placeholder 3"/>
+          <p:cNvSpPr>
+            <a:spLocks noGrp="1"/>
+          </p:cNvSpPr>
+          <p:nvPr>
+            <p:ph type="sldNum" sz="quarter" idx="10"/>
+          </p:nvPr>
+        </p:nvSpPr>
+        <p:spPr/>
+        <p:txBody>
+          <a:bodyPr/>
+          <a:lstStyle/>
+          <a:p>
+            <a:fld id="{F7021451-1387-4CA6-816F-3879F97B5CBC}" type="slidenum">
+              <a:rPr lang="en-US"/>
+              <a:t>24</a:t>
             </a:fld>
             <a:endParaRPr lang="en-US"/>
           </a:p>
@@ -10908,187 +11093,36 @@
           </a:p>
         </p:txBody>
       </p:sp>
-      <p:sp>
-        <p:nvSpPr>
-          <p:cNvPr id="5" name="Text 3"/>
-          <p:cNvSpPr/>
+      <p:pic>
+        <p:nvPicPr>
+          <p:cNvPr id="11" name="Picture 10" descr="A wooden cubes on a stand&#10;&#10;AI-generated content may be incorrect.">
+            <a:extLst>
+              <a:ext uri="{FF2B5EF4-FFF2-40B4-BE49-F238E27FC236}">
+                <a16:creationId xmlns:a16="http://schemas.microsoft.com/office/drawing/2014/main" id="{72A7C797-9746-1073-046B-F02859C2D756}"/>
+              </a:ext>
+            </a:extLst>
+          </p:cNvPr>
+          <p:cNvPicPr>
+            <a:picLocks noChangeAspect="1"/>
+          </p:cNvPicPr>
           <p:nvPr/>
-        </p:nvSpPr>
+        </p:nvPicPr>
+        <p:blipFill>
+          <a:blip r:embed="rId3"/>
+          <a:stretch>
+            <a:fillRect/>
+          </a:stretch>
+        </p:blipFill>
         <p:spPr>
           <a:xfrm>
-            <a:off x="320040" y="868680"/>
-            <a:ext cx="8503920" cy="347472"/>
+            <a:off x="834638" y="1418683"/>
+            <a:ext cx="7251700" cy="2603500"/>
           </a:xfrm>
           <a:prstGeom prst="rect">
             <a:avLst/>
           </a:prstGeom>
-          <a:noFill/>
-          <a:ln/>
         </p:spPr>
-        <p:txBody>
-          <a:bodyPr wrap="square" lIns="0" tIns="0" rIns="0" bIns="0" rtlCol="0" anchor="ctr"/>
-          <a:lstStyle/>
-          <a:p>
-            <a:pPr marL="0" indent="0">
-              <a:buNone/>
-            </a:pPr>
-            <a:r>
-              <a:rPr lang="en-US" sz="1300" dirty="0">
-                <a:solidFill>
-                  <a:srgbClr val="607D8B"/>
-                </a:solidFill>
-                <a:latin typeface="Calibri" pitchFamily="34" charset="0"/>
-                <a:ea typeface="Calibri" pitchFamily="34" charset="-122"/>
-                <a:cs typeface="Calibri" pitchFamily="34" charset="-120"/>
-              </a:rPr>
-              <a:t>Some problems cannot be solved by ANY algorithm — even with infinite time and memory.</a:t>
-            </a:r>
-            <a:endParaRPr lang="en-US" sz="1300" dirty="0"/>
-          </a:p>
-        </p:txBody>
-      </p:sp>
-      <p:sp>
-        <p:nvSpPr>
-          <p:cNvPr id="6" name="Shape 4"/>
-          <p:cNvSpPr/>
-          <p:nvPr/>
-        </p:nvSpPr>
-        <p:spPr>
-          <a:xfrm>
-            <a:off x="274320" y="1261872"/>
-            <a:ext cx="8595360" cy="658368"/>
-          </a:xfrm>
-          <a:prstGeom prst="rect">
-            <a:avLst/>
-          </a:prstGeom>
-          <a:solidFill>
-            <a:srgbClr val="FFFFFF"/>
-          </a:solidFill>
-          <a:ln w="25400">
-            <a:solidFill>
-              <a:srgbClr val="2E7D32"/>
-            </a:solidFill>
-            <a:prstDash val="solid"/>
-          </a:ln>
-        </p:spPr>
-        <p:txBody>
-          <a:bodyPr/>
-          <a:lstStyle/>
-          <a:p>
-            <a:endParaRPr lang="en-US"/>
-          </a:p>
-        </p:txBody>
-      </p:sp>
-      <p:sp>
-        <p:nvSpPr>
-          <p:cNvPr id="7" name="Shape 5"/>
-          <p:cNvSpPr/>
-          <p:nvPr/>
-        </p:nvSpPr>
-        <p:spPr>
-          <a:xfrm>
-            <a:off x="274320" y="1261872"/>
-            <a:ext cx="2103120" cy="658368"/>
-          </a:xfrm>
-          <a:prstGeom prst="rect">
-            <a:avLst/>
-          </a:prstGeom>
-          <a:solidFill>
-            <a:srgbClr val="2E7D32"/>
-          </a:solidFill>
-          <a:ln w="12700">
-            <a:solidFill>
-              <a:srgbClr val="2E7D32"/>
-            </a:solidFill>
-            <a:prstDash val="solid"/>
-          </a:ln>
-        </p:spPr>
-        <p:txBody>
-          <a:bodyPr/>
-          <a:lstStyle/>
-          <a:p>
-            <a:endParaRPr lang="en-US"/>
-          </a:p>
-        </p:txBody>
-      </p:sp>
-      <p:sp>
-        <p:nvSpPr>
-          <p:cNvPr id="8" name="Text 6"/>
-          <p:cNvSpPr/>
-          <p:nvPr/>
-        </p:nvSpPr>
-        <p:spPr>
-          <a:xfrm>
-            <a:off x="274320" y="1261872"/>
-            <a:ext cx="2103120" cy="658368"/>
-          </a:xfrm>
-          <a:prstGeom prst="rect">
-            <a:avLst/>
-          </a:prstGeom>
-          <a:noFill/>
-          <a:ln/>
-        </p:spPr>
-        <p:txBody>
-          <a:bodyPr wrap="square" lIns="0" tIns="0" rIns="0" bIns="0" rtlCol="0" anchor="ctr"/>
-          <a:lstStyle/>
-          <a:p>
-            <a:pPr marL="0" indent="0" algn="ctr">
-              <a:buNone/>
-            </a:pPr>
-            <a:r>
-              <a:rPr lang="en-US" sz="1200" b="1" dirty="0">
-                <a:solidFill>
-                  <a:srgbClr val="FFFFFF"/>
-                </a:solidFill>
-                <a:latin typeface="Georgia" pitchFamily="34" charset="0"/>
-                <a:ea typeface="Georgia" pitchFamily="34" charset="-122"/>
-                <a:cs typeface="Georgia" pitchFamily="34" charset="-120"/>
-              </a:rPr>
-              <a:t>EASY (P)</a:t>
-            </a:r>
-            <a:endParaRPr lang="en-US" sz="1200" dirty="0"/>
-          </a:p>
-        </p:txBody>
-      </p:sp>
-      <p:sp>
-        <p:nvSpPr>
-          <p:cNvPr id="9" name="Text 7"/>
-          <p:cNvSpPr/>
-          <p:nvPr/>
-        </p:nvSpPr>
-        <p:spPr>
-          <a:xfrm>
-            <a:off x="2514600" y="1261872"/>
-            <a:ext cx="6217920" cy="658368"/>
-          </a:xfrm>
-          <a:prstGeom prst="rect">
-            <a:avLst/>
-          </a:prstGeom>
-          <a:noFill/>
-          <a:ln/>
-        </p:spPr>
-        <p:txBody>
-          <a:bodyPr wrap="square" lIns="0" tIns="0" rIns="0" bIns="0" rtlCol="0" anchor="ctr"/>
-          <a:lstStyle/>
-          <a:p>
-            <a:pPr marL="0" indent="0">
-              <a:buNone/>
-            </a:pPr>
-            <a:r>
-              <a:rPr lang="en-US" sz="1300" dirty="0">
-                <a:solidFill>
-                  <a:srgbClr val="1A1A2E"/>
-                </a:solidFill>
-                <a:latin typeface="Calibri" pitchFamily="34" charset="0"/>
-                <a:ea typeface="Calibri" pitchFamily="34" charset="-122"/>
-                <a:cs typeface="Calibri" pitchFamily="34" charset="-120"/>
-              </a:rPr>
-              <a:t>Solvable in polynomial time — O(p(n))</a:t>
-            </a:r>
-            <a:endParaRPr lang="en-US" sz="1300" dirty="0"/>
-          </a:p>
-        </p:txBody>
-      </p:sp>
+      </p:pic>
     </p:spTree>
   </p:cSld>
   <p:clrMapOvr>
@@ -11113,7 +11147,7 @@
         <p:cNvPr id="1" name="">
           <a:extLst>
             <a:ext uri="{FF2B5EF4-FFF2-40B4-BE49-F238E27FC236}">
-              <a16:creationId xmlns:a16="http://schemas.microsoft.com/office/drawing/2014/main" id="{3EC0FE07-1B68-F8A6-8546-864BF60EE6CD}"/>
+              <a16:creationId xmlns:a16="http://schemas.microsoft.com/office/drawing/2014/main" id="{63F19D79-7866-41FB-EC93-B6ACE5C49EEC}"/>
             </a:ext>
           </a:extLst>
         </p:cNvPr>
@@ -11133,7 +11167,7 @@
           <p:cNvPr id="2" name="Shape 0">
             <a:extLst>
               <a:ext uri="{FF2B5EF4-FFF2-40B4-BE49-F238E27FC236}">
-                <a16:creationId xmlns:a16="http://schemas.microsoft.com/office/drawing/2014/main" id="{1A0B16CB-57FD-0EFA-3FE4-1A5C58A393A9}"/>
+                <a16:creationId xmlns:a16="http://schemas.microsoft.com/office/drawing/2014/main" id="{7698E44A-D731-8DED-3ECE-075088A956CD}"/>
               </a:ext>
             </a:extLst>
           </p:cNvPr>
@@ -11171,7 +11205,7 @@
           <p:cNvPr id="3" name="Text 1">
             <a:extLst>
               <a:ext uri="{FF2B5EF4-FFF2-40B4-BE49-F238E27FC236}">
-                <a16:creationId xmlns:a16="http://schemas.microsoft.com/office/drawing/2014/main" id="{8A9A2523-88DA-4D50-342A-BA9CB09F3533}"/>
+                <a16:creationId xmlns:a16="http://schemas.microsoft.com/office/drawing/2014/main" id="{DD2DA474-CB76-3658-DD8E-E8FB65022757}"/>
               </a:ext>
             </a:extLst>
           </p:cNvPr>
@@ -11216,7 +11250,7 @@
           <p:cNvPr id="4" name="Shape 2">
             <a:extLst>
               <a:ext uri="{FF2B5EF4-FFF2-40B4-BE49-F238E27FC236}">
-                <a16:creationId xmlns:a16="http://schemas.microsoft.com/office/drawing/2014/main" id="{9EB52073-4347-8364-8CB2-F9A2F923AFA9}"/>
+                <a16:creationId xmlns:a16="http://schemas.microsoft.com/office/drawing/2014/main" id="{E0074114-0A34-8368-5003-6D569586E69F}"/>
               </a:ext>
             </a:extLst>
           </p:cNvPr>
@@ -11254,7 +11288,7 @@
           <p:cNvPr id="5" name="Text 3">
             <a:extLst>
               <a:ext uri="{FF2B5EF4-FFF2-40B4-BE49-F238E27FC236}">
-                <a16:creationId xmlns:a16="http://schemas.microsoft.com/office/drawing/2014/main" id="{17A5DA14-B56C-2CDC-00E1-23254E594D13}"/>
+                <a16:creationId xmlns:a16="http://schemas.microsoft.com/office/drawing/2014/main" id="{EE571397-3B95-E367-EFE1-55225F795348}"/>
               </a:ext>
             </a:extLst>
           </p:cNvPr>
@@ -11299,7 +11333,7 @@
           <p:cNvPr id="6" name="Shape 4">
             <a:extLst>
               <a:ext uri="{FF2B5EF4-FFF2-40B4-BE49-F238E27FC236}">
-                <a16:creationId xmlns:a16="http://schemas.microsoft.com/office/drawing/2014/main" id="{70559790-501F-4BCD-5FB7-3EBBFE5E0F3F}"/>
+                <a16:creationId xmlns:a16="http://schemas.microsoft.com/office/drawing/2014/main" id="{1A9A32B0-A058-A162-0B95-2D4F1FC4DED0}"/>
               </a:ext>
             </a:extLst>
           </p:cNvPr>
@@ -11337,7 +11371,7 @@
           <p:cNvPr id="7" name="Shape 5">
             <a:extLst>
               <a:ext uri="{FF2B5EF4-FFF2-40B4-BE49-F238E27FC236}">
-                <a16:creationId xmlns:a16="http://schemas.microsoft.com/office/drawing/2014/main" id="{0EB79AD7-4A07-A882-8DDA-05A6B5E1409C}"/>
+                <a16:creationId xmlns:a16="http://schemas.microsoft.com/office/drawing/2014/main" id="{5C590D82-1598-3CC6-1018-FD0EB3AE64A2}"/>
               </a:ext>
             </a:extLst>
           </p:cNvPr>
@@ -11375,7 +11409,7 @@
           <p:cNvPr id="8" name="Text 6">
             <a:extLst>
               <a:ext uri="{FF2B5EF4-FFF2-40B4-BE49-F238E27FC236}">
-                <a16:creationId xmlns:a16="http://schemas.microsoft.com/office/drawing/2014/main" id="{20E21ADE-9488-CBCB-1ED1-7100264A8D99}"/>
+                <a16:creationId xmlns:a16="http://schemas.microsoft.com/office/drawing/2014/main" id="{DF807609-5509-949B-89EC-CB995B693A90}"/>
               </a:ext>
             </a:extLst>
           </p:cNvPr>
@@ -11420,7 +11454,7 @@
           <p:cNvPr id="9" name="Text 7">
             <a:extLst>
               <a:ext uri="{FF2B5EF4-FFF2-40B4-BE49-F238E27FC236}">
-                <a16:creationId xmlns:a16="http://schemas.microsoft.com/office/drawing/2014/main" id="{3D50CA34-09E5-446C-8030-E71202C10AB2}"/>
+                <a16:creationId xmlns:a16="http://schemas.microsoft.com/office/drawing/2014/main" id="{21573172-BD45-DECC-131C-62AC857883EE}"/>
               </a:ext>
             </a:extLst>
           </p:cNvPr>
@@ -11460,176 +11494,10 @@
           </a:p>
         </p:txBody>
       </p:sp>
-      <p:sp>
-        <p:nvSpPr>
-          <p:cNvPr id="10" name="Shape 8">
-            <a:extLst>
-              <a:ext uri="{FF2B5EF4-FFF2-40B4-BE49-F238E27FC236}">
-                <a16:creationId xmlns:a16="http://schemas.microsoft.com/office/drawing/2014/main" id="{DBBF240A-3226-A146-CA5E-0452716185E1}"/>
-              </a:ext>
-            </a:extLst>
-          </p:cNvPr>
-          <p:cNvSpPr/>
-          <p:nvPr/>
-        </p:nvSpPr>
-        <p:spPr>
-          <a:xfrm>
-            <a:off x="274320" y="2039112"/>
-            <a:ext cx="8595360" cy="658368"/>
-          </a:xfrm>
-          <a:prstGeom prst="rect">
-            <a:avLst/>
-          </a:prstGeom>
-          <a:solidFill>
-            <a:srgbClr val="FFFFFF"/>
-          </a:solidFill>
-          <a:ln w="25400">
-            <a:solidFill>
-              <a:srgbClr val="E65100"/>
-            </a:solidFill>
-            <a:prstDash val="solid"/>
-          </a:ln>
-        </p:spPr>
-        <p:txBody>
-          <a:bodyPr/>
-          <a:lstStyle/>
-          <a:p>
-            <a:endParaRPr lang="en-US"/>
-          </a:p>
-        </p:txBody>
-      </p:sp>
-      <p:sp>
-        <p:nvSpPr>
-          <p:cNvPr id="11" name="Shape 9">
-            <a:extLst>
-              <a:ext uri="{FF2B5EF4-FFF2-40B4-BE49-F238E27FC236}">
-                <a16:creationId xmlns:a16="http://schemas.microsoft.com/office/drawing/2014/main" id="{3CC55132-D22D-026A-D94F-A1B8F533275D}"/>
-              </a:ext>
-            </a:extLst>
-          </p:cNvPr>
-          <p:cNvSpPr/>
-          <p:nvPr/>
-        </p:nvSpPr>
-        <p:spPr>
-          <a:xfrm>
-            <a:off x="274320" y="2039112"/>
-            <a:ext cx="2103120" cy="658368"/>
-          </a:xfrm>
-          <a:prstGeom prst="rect">
-            <a:avLst/>
-          </a:prstGeom>
-          <a:solidFill>
-            <a:srgbClr val="E65100"/>
-          </a:solidFill>
-          <a:ln w="12700">
-            <a:solidFill>
-              <a:srgbClr val="E65100"/>
-            </a:solidFill>
-            <a:prstDash val="solid"/>
-          </a:ln>
-        </p:spPr>
-        <p:txBody>
-          <a:bodyPr/>
-          <a:lstStyle/>
-          <a:p>
-            <a:endParaRPr lang="en-US"/>
-          </a:p>
-        </p:txBody>
-      </p:sp>
-      <p:sp>
-        <p:nvSpPr>
-          <p:cNvPr id="12" name="Text 10">
-            <a:extLst>
-              <a:ext uri="{FF2B5EF4-FFF2-40B4-BE49-F238E27FC236}">
-                <a16:creationId xmlns:a16="http://schemas.microsoft.com/office/drawing/2014/main" id="{692C27A7-5838-16C1-8ACE-6486CFFB596A}"/>
-              </a:ext>
-            </a:extLst>
-          </p:cNvPr>
-          <p:cNvSpPr/>
-          <p:nvPr/>
-        </p:nvSpPr>
-        <p:spPr>
-          <a:xfrm>
-            <a:off x="274320" y="2039112"/>
-            <a:ext cx="2103120" cy="658368"/>
-          </a:xfrm>
-          <a:prstGeom prst="rect">
-            <a:avLst/>
-          </a:prstGeom>
-          <a:noFill/>
-          <a:ln/>
-        </p:spPr>
-        <p:txBody>
-          <a:bodyPr wrap="square" lIns="0" tIns="0" rIns="0" bIns="0" rtlCol="0" anchor="ctr"/>
-          <a:lstStyle/>
-          <a:p>
-            <a:pPr marL="0" indent="0" algn="ctr">
-              <a:buNone/>
-            </a:pPr>
-            <a:r>
-              <a:rPr lang="en-US" sz="1200" b="1" dirty="0">
-                <a:solidFill>
-                  <a:srgbClr val="FFFFFF"/>
-                </a:solidFill>
-                <a:latin typeface="Georgia" pitchFamily="34" charset="0"/>
-                <a:ea typeface="Georgia" pitchFamily="34" charset="-122"/>
-                <a:cs typeface="Georgia" pitchFamily="34" charset="-120"/>
-              </a:rPr>
-              <a:t>NP-COMPLETE</a:t>
-            </a:r>
-            <a:endParaRPr lang="en-US" sz="1200" dirty="0"/>
-          </a:p>
-        </p:txBody>
-      </p:sp>
-      <p:sp>
-        <p:nvSpPr>
-          <p:cNvPr id="13" name="Text 11">
-            <a:extLst>
-              <a:ext uri="{FF2B5EF4-FFF2-40B4-BE49-F238E27FC236}">
-                <a16:creationId xmlns:a16="http://schemas.microsoft.com/office/drawing/2014/main" id="{B4BF4F6B-3C45-4B15-897A-C4BA2DEF2404}"/>
-              </a:ext>
-            </a:extLst>
-          </p:cNvPr>
-          <p:cNvSpPr/>
-          <p:nvPr/>
-        </p:nvSpPr>
-        <p:spPr>
-          <a:xfrm>
-            <a:off x="2514600" y="2039112"/>
-            <a:ext cx="6217920" cy="658368"/>
-          </a:xfrm>
-          <a:prstGeom prst="rect">
-            <a:avLst/>
-          </a:prstGeom>
-          <a:noFill/>
-          <a:ln/>
-        </p:spPr>
-        <p:txBody>
-          <a:bodyPr wrap="square" lIns="0" tIns="0" rIns="0" bIns="0" rtlCol="0" anchor="ctr"/>
-          <a:lstStyle/>
-          <a:p>
-            <a:pPr marL="0" indent="0">
-              <a:buNone/>
-            </a:pPr>
-            <a:r>
-              <a:rPr lang="en-US" sz="1300" dirty="0">
-                <a:solidFill>
-                  <a:srgbClr val="1A1A2E"/>
-                </a:solidFill>
-                <a:latin typeface="Calibri" pitchFamily="34" charset="0"/>
-                <a:ea typeface="Calibri" pitchFamily="34" charset="-122"/>
-                <a:cs typeface="Calibri" pitchFamily="34" charset="-120"/>
-              </a:rPr>
-              <a:t>Solvable, but all currently known algorithms are exponential</a:t>
-            </a:r>
-            <a:endParaRPr lang="en-US" sz="1300" dirty="0"/>
-          </a:p>
-        </p:txBody>
-      </p:sp>
     </p:spTree>
     <p:extLst>
       <p:ext uri="{BB962C8B-B14F-4D97-AF65-F5344CB8AC3E}">
-        <p14:creationId xmlns:p14="http://schemas.microsoft.com/office/powerpoint/2010/main" val="2092169922"/>
+        <p14:creationId xmlns:p14="http://schemas.microsoft.com/office/powerpoint/2010/main" val="1515791411"/>
       </p:ext>
     </p:extLst>
   </p:cSld>
@@ -13854,7 +13722,7 @@
         <p:cNvPr id="1" name="">
           <a:extLst>
             <a:ext uri="{FF2B5EF4-FFF2-40B4-BE49-F238E27FC236}">
-              <a16:creationId xmlns:a16="http://schemas.microsoft.com/office/drawing/2014/main" id="{C9BE10E3-0EA9-802F-200E-775C3057AC03}"/>
+              <a16:creationId xmlns:a16="http://schemas.microsoft.com/office/drawing/2014/main" id="{3EC0FE07-1B68-F8A6-8546-864BF60EE6CD}"/>
             </a:ext>
           </a:extLst>
         </p:cNvPr>
@@ -13874,7 +13742,7 @@
           <p:cNvPr id="2" name="Shape 0">
             <a:extLst>
               <a:ext uri="{FF2B5EF4-FFF2-40B4-BE49-F238E27FC236}">
-                <a16:creationId xmlns:a16="http://schemas.microsoft.com/office/drawing/2014/main" id="{9CC1C135-8EC9-FD28-DEFD-11830A2F640F}"/>
+                <a16:creationId xmlns:a16="http://schemas.microsoft.com/office/drawing/2014/main" id="{1A0B16CB-57FD-0EFA-3FE4-1A5C58A393A9}"/>
               </a:ext>
             </a:extLst>
           </p:cNvPr>
@@ -13912,7 +13780,7 @@
           <p:cNvPr id="3" name="Text 1">
             <a:extLst>
               <a:ext uri="{FF2B5EF4-FFF2-40B4-BE49-F238E27FC236}">
-                <a16:creationId xmlns:a16="http://schemas.microsoft.com/office/drawing/2014/main" id="{337C0D53-7645-0DF1-8C13-5787EA6D36DF}"/>
+                <a16:creationId xmlns:a16="http://schemas.microsoft.com/office/drawing/2014/main" id="{8A9A2523-88DA-4D50-342A-BA9CB09F3533}"/>
               </a:ext>
             </a:extLst>
           </p:cNvPr>
@@ -13957,7 +13825,7 @@
           <p:cNvPr id="4" name="Shape 2">
             <a:extLst>
               <a:ext uri="{FF2B5EF4-FFF2-40B4-BE49-F238E27FC236}">
-                <a16:creationId xmlns:a16="http://schemas.microsoft.com/office/drawing/2014/main" id="{6BE25B65-1907-B147-A1F7-E6A230929E91}"/>
+                <a16:creationId xmlns:a16="http://schemas.microsoft.com/office/drawing/2014/main" id="{9EB52073-4347-8364-8CB2-F9A2F923AFA9}"/>
               </a:ext>
             </a:extLst>
           </p:cNvPr>
@@ -13995,7 +13863,7 @@
           <p:cNvPr id="5" name="Text 3">
             <a:extLst>
               <a:ext uri="{FF2B5EF4-FFF2-40B4-BE49-F238E27FC236}">
-                <a16:creationId xmlns:a16="http://schemas.microsoft.com/office/drawing/2014/main" id="{7065E184-628F-43AC-731B-16203505BA25}"/>
+                <a16:creationId xmlns:a16="http://schemas.microsoft.com/office/drawing/2014/main" id="{17A5DA14-B56C-2CDC-00E1-23254E594D13}"/>
               </a:ext>
             </a:extLst>
           </p:cNvPr>
@@ -14040,7 +13908,7 @@
           <p:cNvPr id="6" name="Shape 4">
             <a:extLst>
               <a:ext uri="{FF2B5EF4-FFF2-40B4-BE49-F238E27FC236}">
-                <a16:creationId xmlns:a16="http://schemas.microsoft.com/office/drawing/2014/main" id="{57416190-E7ED-6F15-8E3B-EB18E9A7839F}"/>
+                <a16:creationId xmlns:a16="http://schemas.microsoft.com/office/drawing/2014/main" id="{70559790-501F-4BCD-5FB7-3EBBFE5E0F3F}"/>
               </a:ext>
             </a:extLst>
           </p:cNvPr>
@@ -14078,7 +13946,7 @@
           <p:cNvPr id="7" name="Shape 5">
             <a:extLst>
               <a:ext uri="{FF2B5EF4-FFF2-40B4-BE49-F238E27FC236}">
-                <a16:creationId xmlns:a16="http://schemas.microsoft.com/office/drawing/2014/main" id="{FE3789B6-7B42-E620-C06E-735D89E6492F}"/>
+                <a16:creationId xmlns:a16="http://schemas.microsoft.com/office/drawing/2014/main" id="{0EB79AD7-4A07-A882-8DDA-05A6B5E1409C}"/>
               </a:ext>
             </a:extLst>
           </p:cNvPr>
@@ -14116,7 +13984,7 @@
           <p:cNvPr id="8" name="Text 6">
             <a:extLst>
               <a:ext uri="{FF2B5EF4-FFF2-40B4-BE49-F238E27FC236}">
-                <a16:creationId xmlns:a16="http://schemas.microsoft.com/office/drawing/2014/main" id="{5C3849FE-1E79-FF57-FEE5-60F976339E6D}"/>
+                <a16:creationId xmlns:a16="http://schemas.microsoft.com/office/drawing/2014/main" id="{20E21ADE-9488-CBCB-1ED1-7100264A8D99}"/>
               </a:ext>
             </a:extLst>
           </p:cNvPr>
@@ -14161,7 +14029,7 @@
           <p:cNvPr id="9" name="Text 7">
             <a:extLst>
               <a:ext uri="{FF2B5EF4-FFF2-40B4-BE49-F238E27FC236}">
-                <a16:creationId xmlns:a16="http://schemas.microsoft.com/office/drawing/2014/main" id="{95E3DC79-CAF9-143E-D734-1AF94F6E0A43}"/>
+                <a16:creationId xmlns:a16="http://schemas.microsoft.com/office/drawing/2014/main" id="{3D50CA34-09E5-446C-8030-E71202C10AB2}"/>
               </a:ext>
             </a:extLst>
           </p:cNvPr>
@@ -14206,7 +14074,7 @@
           <p:cNvPr id="10" name="Shape 8">
             <a:extLst>
               <a:ext uri="{FF2B5EF4-FFF2-40B4-BE49-F238E27FC236}">
-                <a16:creationId xmlns:a16="http://schemas.microsoft.com/office/drawing/2014/main" id="{164F279B-FC36-5A86-D434-0127E5A7B511}"/>
+                <a16:creationId xmlns:a16="http://schemas.microsoft.com/office/drawing/2014/main" id="{DBBF240A-3226-A146-CA5E-0452716185E1}"/>
               </a:ext>
             </a:extLst>
           </p:cNvPr>
@@ -14244,7 +14112,7 @@
           <p:cNvPr id="11" name="Shape 9">
             <a:extLst>
               <a:ext uri="{FF2B5EF4-FFF2-40B4-BE49-F238E27FC236}">
-                <a16:creationId xmlns:a16="http://schemas.microsoft.com/office/drawing/2014/main" id="{F5BAA6F4-2157-0BBC-AA19-529CB3F721E8}"/>
+                <a16:creationId xmlns:a16="http://schemas.microsoft.com/office/drawing/2014/main" id="{3CC55132-D22D-026A-D94F-A1B8F533275D}"/>
               </a:ext>
             </a:extLst>
           </p:cNvPr>
@@ -14282,6 +14150,548 @@
           <p:cNvPr id="12" name="Text 10">
             <a:extLst>
               <a:ext uri="{FF2B5EF4-FFF2-40B4-BE49-F238E27FC236}">
+                <a16:creationId xmlns:a16="http://schemas.microsoft.com/office/drawing/2014/main" id="{692C27A7-5838-16C1-8ACE-6486CFFB596A}"/>
+              </a:ext>
+            </a:extLst>
+          </p:cNvPr>
+          <p:cNvSpPr/>
+          <p:nvPr/>
+        </p:nvSpPr>
+        <p:spPr>
+          <a:xfrm>
+            <a:off x="274320" y="2039112"/>
+            <a:ext cx="2103120" cy="658368"/>
+          </a:xfrm>
+          <a:prstGeom prst="rect">
+            <a:avLst/>
+          </a:prstGeom>
+          <a:noFill/>
+          <a:ln/>
+        </p:spPr>
+        <p:txBody>
+          <a:bodyPr wrap="square" lIns="0" tIns="0" rIns="0" bIns="0" rtlCol="0" anchor="ctr"/>
+          <a:lstStyle/>
+          <a:p>
+            <a:pPr marL="0" indent="0" algn="ctr">
+              <a:buNone/>
+            </a:pPr>
+            <a:r>
+              <a:rPr lang="en-US" sz="1200" b="1" dirty="0">
+                <a:solidFill>
+                  <a:srgbClr val="FFFFFF"/>
+                </a:solidFill>
+                <a:latin typeface="Georgia" pitchFamily="34" charset="0"/>
+                <a:ea typeface="Georgia" pitchFamily="34" charset="-122"/>
+                <a:cs typeface="Georgia" pitchFamily="34" charset="-120"/>
+              </a:rPr>
+              <a:t>NP-COMPLETE</a:t>
+            </a:r>
+            <a:endParaRPr lang="en-US" sz="1200" dirty="0"/>
+          </a:p>
+        </p:txBody>
+      </p:sp>
+      <p:sp>
+        <p:nvSpPr>
+          <p:cNvPr id="13" name="Text 11">
+            <a:extLst>
+              <a:ext uri="{FF2B5EF4-FFF2-40B4-BE49-F238E27FC236}">
+                <a16:creationId xmlns:a16="http://schemas.microsoft.com/office/drawing/2014/main" id="{B4BF4F6B-3C45-4B15-897A-C4BA2DEF2404}"/>
+              </a:ext>
+            </a:extLst>
+          </p:cNvPr>
+          <p:cNvSpPr/>
+          <p:nvPr/>
+        </p:nvSpPr>
+        <p:spPr>
+          <a:xfrm>
+            <a:off x="2514600" y="2039112"/>
+            <a:ext cx="6217920" cy="658368"/>
+          </a:xfrm>
+          <a:prstGeom prst="rect">
+            <a:avLst/>
+          </a:prstGeom>
+          <a:noFill/>
+          <a:ln/>
+        </p:spPr>
+        <p:txBody>
+          <a:bodyPr wrap="square" lIns="0" tIns="0" rIns="0" bIns="0" rtlCol="0" anchor="ctr"/>
+          <a:lstStyle/>
+          <a:p>
+            <a:pPr marL="0" indent="0">
+              <a:buNone/>
+            </a:pPr>
+            <a:r>
+              <a:rPr lang="en-US" sz="1300" dirty="0">
+                <a:solidFill>
+                  <a:srgbClr val="1A1A2E"/>
+                </a:solidFill>
+                <a:latin typeface="Calibri" pitchFamily="34" charset="0"/>
+                <a:ea typeface="Calibri" pitchFamily="34" charset="-122"/>
+                <a:cs typeface="Calibri" pitchFamily="34" charset="-120"/>
+              </a:rPr>
+              <a:t>Solvable, but all currently known algorithms are exponential</a:t>
+            </a:r>
+            <a:endParaRPr lang="en-US" sz="1300" dirty="0"/>
+          </a:p>
+        </p:txBody>
+      </p:sp>
+    </p:spTree>
+    <p:extLst>
+      <p:ext uri="{BB962C8B-B14F-4D97-AF65-F5344CB8AC3E}">
+        <p14:creationId xmlns:p14="http://schemas.microsoft.com/office/powerpoint/2010/main" val="2092169922"/>
+      </p:ext>
+    </p:extLst>
+  </p:cSld>
+  <p:clrMapOvr>
+    <a:masterClrMapping/>
+  </p:clrMapOvr>
+</p:sld>
+</file>
+
+<file path=ppt/slides/slide21.xml><?xml version="1.0" encoding="utf-8"?>
+<p:sld xmlns:a="http://schemas.openxmlformats.org/drawingml/2006/main" xmlns:r="http://schemas.openxmlformats.org/officeDocument/2006/relationships" xmlns:p="http://schemas.openxmlformats.org/presentationml/2006/main">
+  <p:cSld>
+    <p:bg>
+      <p:bgPr>
+        <a:solidFill>
+          <a:srgbClr val="F8FAFD"/>
+        </a:solidFill>
+        <a:effectLst/>
+      </p:bgPr>
+    </p:bg>
+    <p:spTree>
+      <p:nvGrpSpPr>
+        <p:cNvPr id="1" name="">
+          <a:extLst>
+            <a:ext uri="{FF2B5EF4-FFF2-40B4-BE49-F238E27FC236}">
+              <a16:creationId xmlns:a16="http://schemas.microsoft.com/office/drawing/2014/main" id="{C9BE10E3-0EA9-802F-200E-775C3057AC03}"/>
+            </a:ext>
+          </a:extLst>
+        </p:cNvPr>
+        <p:cNvGrpSpPr/>
+        <p:nvPr/>
+      </p:nvGrpSpPr>
+      <p:grpSpPr>
+        <a:xfrm>
+          <a:off x="0" y="0"/>
+          <a:ext cx="0" cy="0"/>
+          <a:chOff x="0" y="0"/>
+          <a:chExt cx="0" cy="0"/>
+        </a:xfrm>
+      </p:grpSpPr>
+      <p:sp>
+        <p:nvSpPr>
+          <p:cNvPr id="2" name="Shape 0">
+            <a:extLst>
+              <a:ext uri="{FF2B5EF4-FFF2-40B4-BE49-F238E27FC236}">
+                <a16:creationId xmlns:a16="http://schemas.microsoft.com/office/drawing/2014/main" id="{9CC1C135-8EC9-FD28-DEFD-11830A2F640F}"/>
+              </a:ext>
+            </a:extLst>
+          </p:cNvPr>
+          <p:cNvSpPr/>
+          <p:nvPr/>
+        </p:nvSpPr>
+        <p:spPr>
+          <a:xfrm>
+            <a:off x="0" y="0"/>
+            <a:ext cx="9144000" cy="777240"/>
+          </a:xfrm>
+          <a:prstGeom prst="rect">
+            <a:avLst/>
+          </a:prstGeom>
+          <a:solidFill>
+            <a:srgbClr val="0D1B2A"/>
+          </a:solidFill>
+          <a:ln w="12700">
+            <a:solidFill>
+              <a:srgbClr val="0D1B2A"/>
+            </a:solidFill>
+            <a:prstDash val="solid"/>
+          </a:ln>
+        </p:spPr>
+        <p:txBody>
+          <a:bodyPr/>
+          <a:lstStyle/>
+          <a:p>
+            <a:endParaRPr lang="en-US"/>
+          </a:p>
+        </p:txBody>
+      </p:sp>
+      <p:sp>
+        <p:nvSpPr>
+          <p:cNvPr id="3" name="Text 1">
+            <a:extLst>
+              <a:ext uri="{FF2B5EF4-FFF2-40B4-BE49-F238E27FC236}">
+                <a16:creationId xmlns:a16="http://schemas.microsoft.com/office/drawing/2014/main" id="{337C0D53-7645-0DF1-8C13-5787EA6D36DF}"/>
+              </a:ext>
+            </a:extLst>
+          </p:cNvPr>
+          <p:cNvSpPr/>
+          <p:nvPr/>
+        </p:nvSpPr>
+        <p:spPr>
+          <a:xfrm>
+            <a:off x="320040" y="0"/>
+            <a:ext cx="8503920" cy="777240"/>
+          </a:xfrm>
+          <a:prstGeom prst="rect">
+            <a:avLst/>
+          </a:prstGeom>
+          <a:noFill/>
+          <a:ln/>
+        </p:spPr>
+        <p:txBody>
+          <a:bodyPr wrap="square" lIns="0" tIns="0" rIns="0" bIns="0" rtlCol="0" anchor="ctr"/>
+          <a:lstStyle/>
+          <a:p>
+            <a:pPr marL="0" indent="0">
+              <a:buNone/>
+            </a:pPr>
+            <a:r>
+              <a:rPr lang="en-US" sz="2400" b="1" dirty="0">
+                <a:solidFill>
+                  <a:srgbClr val="FFFFFF"/>
+                </a:solidFill>
+                <a:latin typeface="Georgia" pitchFamily="34" charset="0"/>
+                <a:ea typeface="Georgia" pitchFamily="34" charset="-122"/>
+                <a:cs typeface="Georgia" pitchFamily="34" charset="-120"/>
+              </a:rPr>
+              <a:t>Undecidable Problems: Beyond Hard</a:t>
+            </a:r>
+            <a:endParaRPr lang="en-US" sz="2400" dirty="0"/>
+          </a:p>
+        </p:txBody>
+      </p:sp>
+      <p:sp>
+        <p:nvSpPr>
+          <p:cNvPr id="4" name="Shape 2">
+            <a:extLst>
+              <a:ext uri="{FF2B5EF4-FFF2-40B4-BE49-F238E27FC236}">
+                <a16:creationId xmlns:a16="http://schemas.microsoft.com/office/drawing/2014/main" id="{6BE25B65-1907-B147-A1F7-E6A230929E91}"/>
+              </a:ext>
+            </a:extLst>
+          </p:cNvPr>
+          <p:cNvSpPr/>
+          <p:nvPr/>
+        </p:nvSpPr>
+        <p:spPr>
+          <a:xfrm>
+            <a:off x="0" y="777240"/>
+            <a:ext cx="9144000" cy="64008"/>
+          </a:xfrm>
+          <a:prstGeom prst="rect">
+            <a:avLst/>
+          </a:prstGeom>
+          <a:solidFill>
+            <a:srgbClr val="00BCD4"/>
+          </a:solidFill>
+          <a:ln w="12700">
+            <a:solidFill>
+              <a:srgbClr val="00BCD4"/>
+            </a:solidFill>
+            <a:prstDash val="solid"/>
+          </a:ln>
+        </p:spPr>
+        <p:txBody>
+          <a:bodyPr/>
+          <a:lstStyle/>
+          <a:p>
+            <a:endParaRPr lang="en-US"/>
+          </a:p>
+        </p:txBody>
+      </p:sp>
+      <p:sp>
+        <p:nvSpPr>
+          <p:cNvPr id="5" name="Text 3">
+            <a:extLst>
+              <a:ext uri="{FF2B5EF4-FFF2-40B4-BE49-F238E27FC236}">
+                <a16:creationId xmlns:a16="http://schemas.microsoft.com/office/drawing/2014/main" id="{7065E184-628F-43AC-731B-16203505BA25}"/>
+              </a:ext>
+            </a:extLst>
+          </p:cNvPr>
+          <p:cNvSpPr/>
+          <p:nvPr/>
+        </p:nvSpPr>
+        <p:spPr>
+          <a:xfrm>
+            <a:off x="320040" y="868680"/>
+            <a:ext cx="8503920" cy="347472"/>
+          </a:xfrm>
+          <a:prstGeom prst="rect">
+            <a:avLst/>
+          </a:prstGeom>
+          <a:noFill/>
+          <a:ln/>
+        </p:spPr>
+        <p:txBody>
+          <a:bodyPr wrap="square" lIns="0" tIns="0" rIns="0" bIns="0" rtlCol="0" anchor="ctr"/>
+          <a:lstStyle/>
+          <a:p>
+            <a:pPr marL="0" indent="0">
+              <a:buNone/>
+            </a:pPr>
+            <a:r>
+              <a:rPr lang="en-US" sz="1300" dirty="0">
+                <a:solidFill>
+                  <a:srgbClr val="607D8B"/>
+                </a:solidFill>
+                <a:latin typeface="Calibri" pitchFamily="34" charset="0"/>
+                <a:ea typeface="Calibri" pitchFamily="34" charset="-122"/>
+                <a:cs typeface="Calibri" pitchFamily="34" charset="-120"/>
+              </a:rPr>
+              <a:t>Some problems cannot be solved by ANY algorithm — even with infinite time and memory.</a:t>
+            </a:r>
+            <a:endParaRPr lang="en-US" sz="1300" dirty="0"/>
+          </a:p>
+        </p:txBody>
+      </p:sp>
+      <p:sp>
+        <p:nvSpPr>
+          <p:cNvPr id="6" name="Shape 4">
+            <a:extLst>
+              <a:ext uri="{FF2B5EF4-FFF2-40B4-BE49-F238E27FC236}">
+                <a16:creationId xmlns:a16="http://schemas.microsoft.com/office/drawing/2014/main" id="{57416190-E7ED-6F15-8E3B-EB18E9A7839F}"/>
+              </a:ext>
+            </a:extLst>
+          </p:cNvPr>
+          <p:cNvSpPr/>
+          <p:nvPr/>
+        </p:nvSpPr>
+        <p:spPr>
+          <a:xfrm>
+            <a:off x="274320" y="1261872"/>
+            <a:ext cx="8595360" cy="658368"/>
+          </a:xfrm>
+          <a:prstGeom prst="rect">
+            <a:avLst/>
+          </a:prstGeom>
+          <a:solidFill>
+            <a:srgbClr val="FFFFFF"/>
+          </a:solidFill>
+          <a:ln w="25400">
+            <a:solidFill>
+              <a:srgbClr val="2E7D32"/>
+            </a:solidFill>
+            <a:prstDash val="solid"/>
+          </a:ln>
+        </p:spPr>
+        <p:txBody>
+          <a:bodyPr/>
+          <a:lstStyle/>
+          <a:p>
+            <a:endParaRPr lang="en-US"/>
+          </a:p>
+        </p:txBody>
+      </p:sp>
+      <p:sp>
+        <p:nvSpPr>
+          <p:cNvPr id="7" name="Shape 5">
+            <a:extLst>
+              <a:ext uri="{FF2B5EF4-FFF2-40B4-BE49-F238E27FC236}">
+                <a16:creationId xmlns:a16="http://schemas.microsoft.com/office/drawing/2014/main" id="{FE3789B6-7B42-E620-C06E-735D89E6492F}"/>
+              </a:ext>
+            </a:extLst>
+          </p:cNvPr>
+          <p:cNvSpPr/>
+          <p:nvPr/>
+        </p:nvSpPr>
+        <p:spPr>
+          <a:xfrm>
+            <a:off x="274320" y="1261872"/>
+            <a:ext cx="2103120" cy="658368"/>
+          </a:xfrm>
+          <a:prstGeom prst="rect">
+            <a:avLst/>
+          </a:prstGeom>
+          <a:solidFill>
+            <a:srgbClr val="2E7D32"/>
+          </a:solidFill>
+          <a:ln w="12700">
+            <a:solidFill>
+              <a:srgbClr val="2E7D32"/>
+            </a:solidFill>
+            <a:prstDash val="solid"/>
+          </a:ln>
+        </p:spPr>
+        <p:txBody>
+          <a:bodyPr/>
+          <a:lstStyle/>
+          <a:p>
+            <a:endParaRPr lang="en-US"/>
+          </a:p>
+        </p:txBody>
+      </p:sp>
+      <p:sp>
+        <p:nvSpPr>
+          <p:cNvPr id="8" name="Text 6">
+            <a:extLst>
+              <a:ext uri="{FF2B5EF4-FFF2-40B4-BE49-F238E27FC236}">
+                <a16:creationId xmlns:a16="http://schemas.microsoft.com/office/drawing/2014/main" id="{5C3849FE-1E79-FF57-FEE5-60F976339E6D}"/>
+              </a:ext>
+            </a:extLst>
+          </p:cNvPr>
+          <p:cNvSpPr/>
+          <p:nvPr/>
+        </p:nvSpPr>
+        <p:spPr>
+          <a:xfrm>
+            <a:off x="274320" y="1261872"/>
+            <a:ext cx="2103120" cy="658368"/>
+          </a:xfrm>
+          <a:prstGeom prst="rect">
+            <a:avLst/>
+          </a:prstGeom>
+          <a:noFill/>
+          <a:ln/>
+        </p:spPr>
+        <p:txBody>
+          <a:bodyPr wrap="square" lIns="0" tIns="0" rIns="0" bIns="0" rtlCol="0" anchor="ctr"/>
+          <a:lstStyle/>
+          <a:p>
+            <a:pPr marL="0" indent="0" algn="ctr">
+              <a:buNone/>
+            </a:pPr>
+            <a:r>
+              <a:rPr lang="en-US" sz="1200" b="1" dirty="0">
+                <a:solidFill>
+                  <a:srgbClr val="FFFFFF"/>
+                </a:solidFill>
+                <a:latin typeface="Georgia" pitchFamily="34" charset="0"/>
+                <a:ea typeface="Georgia" pitchFamily="34" charset="-122"/>
+                <a:cs typeface="Georgia" pitchFamily="34" charset="-120"/>
+              </a:rPr>
+              <a:t>EASY (P)</a:t>
+            </a:r>
+            <a:endParaRPr lang="en-US" sz="1200" dirty="0"/>
+          </a:p>
+        </p:txBody>
+      </p:sp>
+      <p:sp>
+        <p:nvSpPr>
+          <p:cNvPr id="9" name="Text 7">
+            <a:extLst>
+              <a:ext uri="{FF2B5EF4-FFF2-40B4-BE49-F238E27FC236}">
+                <a16:creationId xmlns:a16="http://schemas.microsoft.com/office/drawing/2014/main" id="{95E3DC79-CAF9-143E-D734-1AF94F6E0A43}"/>
+              </a:ext>
+            </a:extLst>
+          </p:cNvPr>
+          <p:cNvSpPr/>
+          <p:nvPr/>
+        </p:nvSpPr>
+        <p:spPr>
+          <a:xfrm>
+            <a:off x="2514600" y="1261872"/>
+            <a:ext cx="6217920" cy="658368"/>
+          </a:xfrm>
+          <a:prstGeom prst="rect">
+            <a:avLst/>
+          </a:prstGeom>
+          <a:noFill/>
+          <a:ln/>
+        </p:spPr>
+        <p:txBody>
+          <a:bodyPr wrap="square" lIns="0" tIns="0" rIns="0" bIns="0" rtlCol="0" anchor="ctr"/>
+          <a:lstStyle/>
+          <a:p>
+            <a:pPr marL="0" indent="0">
+              <a:buNone/>
+            </a:pPr>
+            <a:r>
+              <a:rPr lang="en-US" sz="1300" dirty="0">
+                <a:solidFill>
+                  <a:srgbClr val="1A1A2E"/>
+                </a:solidFill>
+                <a:latin typeface="Calibri" pitchFamily="34" charset="0"/>
+                <a:ea typeface="Calibri" pitchFamily="34" charset="-122"/>
+                <a:cs typeface="Calibri" pitchFamily="34" charset="-120"/>
+              </a:rPr>
+              <a:t>Solvable in polynomial time — O(p(n))</a:t>
+            </a:r>
+            <a:endParaRPr lang="en-US" sz="1300" dirty="0"/>
+          </a:p>
+        </p:txBody>
+      </p:sp>
+      <p:sp>
+        <p:nvSpPr>
+          <p:cNvPr id="10" name="Shape 8">
+            <a:extLst>
+              <a:ext uri="{FF2B5EF4-FFF2-40B4-BE49-F238E27FC236}">
+                <a16:creationId xmlns:a16="http://schemas.microsoft.com/office/drawing/2014/main" id="{164F279B-FC36-5A86-D434-0127E5A7B511}"/>
+              </a:ext>
+            </a:extLst>
+          </p:cNvPr>
+          <p:cNvSpPr/>
+          <p:nvPr/>
+        </p:nvSpPr>
+        <p:spPr>
+          <a:xfrm>
+            <a:off x="274320" y="2039112"/>
+            <a:ext cx="8595360" cy="658368"/>
+          </a:xfrm>
+          <a:prstGeom prst="rect">
+            <a:avLst/>
+          </a:prstGeom>
+          <a:solidFill>
+            <a:srgbClr val="FFFFFF"/>
+          </a:solidFill>
+          <a:ln w="25400">
+            <a:solidFill>
+              <a:srgbClr val="E65100"/>
+            </a:solidFill>
+            <a:prstDash val="solid"/>
+          </a:ln>
+        </p:spPr>
+        <p:txBody>
+          <a:bodyPr/>
+          <a:lstStyle/>
+          <a:p>
+            <a:endParaRPr lang="en-US"/>
+          </a:p>
+        </p:txBody>
+      </p:sp>
+      <p:sp>
+        <p:nvSpPr>
+          <p:cNvPr id="11" name="Shape 9">
+            <a:extLst>
+              <a:ext uri="{FF2B5EF4-FFF2-40B4-BE49-F238E27FC236}">
+                <a16:creationId xmlns:a16="http://schemas.microsoft.com/office/drawing/2014/main" id="{F5BAA6F4-2157-0BBC-AA19-529CB3F721E8}"/>
+              </a:ext>
+            </a:extLst>
+          </p:cNvPr>
+          <p:cNvSpPr/>
+          <p:nvPr/>
+        </p:nvSpPr>
+        <p:spPr>
+          <a:xfrm>
+            <a:off x="274320" y="2039112"/>
+            <a:ext cx="2103120" cy="658368"/>
+          </a:xfrm>
+          <a:prstGeom prst="rect">
+            <a:avLst/>
+          </a:prstGeom>
+          <a:solidFill>
+            <a:srgbClr val="E65100"/>
+          </a:solidFill>
+          <a:ln w="12700">
+            <a:solidFill>
+              <a:srgbClr val="E65100"/>
+            </a:solidFill>
+            <a:prstDash val="solid"/>
+          </a:ln>
+        </p:spPr>
+        <p:txBody>
+          <a:bodyPr/>
+          <a:lstStyle/>
+          <a:p>
+            <a:endParaRPr lang="en-US"/>
+          </a:p>
+        </p:txBody>
+      </p:sp>
+      <p:sp>
+        <p:nvSpPr>
+          <p:cNvPr id="12" name="Text 10">
+            <a:extLst>
+              <a:ext uri="{FF2B5EF4-FFF2-40B4-BE49-F238E27FC236}">
                 <a16:creationId xmlns:a16="http://schemas.microsoft.com/office/drawing/2014/main" id="{BF8FCE12-8C7B-49E9-1FDC-29221D888648}"/>
               </a:ext>
             </a:extLst>
@@ -14546,7 +14956,7 @@
 </p:sld>
 </file>
 
-<file path=ppt/slides/slide21.xml><?xml version="1.0" encoding="utf-8"?>
+<file path=ppt/slides/slide22.xml><?xml version="1.0" encoding="utf-8"?>
 <p:sld xmlns:a="http://schemas.openxmlformats.org/drawingml/2006/main" xmlns:r="http://schemas.openxmlformats.org/officeDocument/2006/relationships" xmlns:p="http://schemas.openxmlformats.org/presentationml/2006/main">
   <p:cSld>
     <p:bg>
@@ -15470,7 +15880,7 @@
 </p:sld>
 </file>
 
-<file path=ppt/slides/slide22.xml><?xml version="1.0" encoding="utf-8"?>
+<file path=ppt/slides/slide23.xml><?xml version="1.0" encoding="utf-8"?>
 <p:sld xmlns:a="http://schemas.openxmlformats.org/drawingml/2006/main" xmlns:r="http://schemas.openxmlformats.org/officeDocument/2006/relationships" xmlns:p="http://schemas.openxmlformats.org/presentationml/2006/main">
   <p:cSld name="Slide 9">
     <p:bg>
@@ -15950,7 +16360,7 @@
 </p:sld>
 </file>
 
-<file path=ppt/slides/slide23.xml><?xml version="1.0" encoding="utf-8"?>
+<file path=ppt/slides/slide24.xml><?xml version="1.0" encoding="utf-8"?>
 <p:sld xmlns:a="http://schemas.openxmlformats.org/drawingml/2006/main" xmlns:r="http://schemas.openxmlformats.org/officeDocument/2006/relationships" xmlns:p="http://schemas.openxmlformats.org/presentationml/2006/main">
   <p:cSld name="Slide 10">
     <p:bg>

</xml_diff>